<commit_message>
Updates and additons to graduate project slides
</commit_message>
<xml_diff>
--- a/SupplementaryMaterials/GraduateIndependentProject.pptx
+++ b/SupplementaryMaterials/GraduateIndependentProject.pptx
@@ -264,7 +264,7 @@
           <a:p>
             <a:fld id="{41EA29B2-5B60-4524-9406-F439795E8972}" type="datetimeFigureOut">
               <a:rPr lang="en-US" smtClean="0"/>
-              <a:t>7/4/2026</a:t>
+              <a:t>9/28/2026</a:t>
             </a:fld>
             <a:endParaRPr lang="en-US"/>
           </a:p>
@@ -462,7 +462,7 @@
           <a:p>
             <a:fld id="{41EA29B2-5B60-4524-9406-F439795E8972}" type="datetimeFigureOut">
               <a:rPr lang="en-US" smtClean="0"/>
-              <a:t>7/4/2026</a:t>
+              <a:t>9/28/2026</a:t>
             </a:fld>
             <a:endParaRPr lang="en-US"/>
           </a:p>
@@ -670,7 +670,7 @@
           <a:p>
             <a:fld id="{41EA29B2-5B60-4524-9406-F439795E8972}" type="datetimeFigureOut">
               <a:rPr lang="en-US" smtClean="0"/>
-              <a:t>7/4/2026</a:t>
+              <a:t>9/28/2026</a:t>
             </a:fld>
             <a:endParaRPr lang="en-US"/>
           </a:p>
@@ -868,7 +868,7 @@
           <a:p>
             <a:fld id="{41EA29B2-5B60-4524-9406-F439795E8972}" type="datetimeFigureOut">
               <a:rPr lang="en-US" smtClean="0"/>
-              <a:t>7/4/2026</a:t>
+              <a:t>9/28/2026</a:t>
             </a:fld>
             <a:endParaRPr lang="en-US"/>
           </a:p>
@@ -1143,7 +1143,7 @@
           <a:p>
             <a:fld id="{41EA29B2-5B60-4524-9406-F439795E8972}" type="datetimeFigureOut">
               <a:rPr lang="en-US" smtClean="0"/>
-              <a:t>7/4/2026</a:t>
+              <a:t>9/28/2026</a:t>
             </a:fld>
             <a:endParaRPr lang="en-US"/>
           </a:p>
@@ -1408,7 +1408,7 @@
           <a:p>
             <a:fld id="{41EA29B2-5B60-4524-9406-F439795E8972}" type="datetimeFigureOut">
               <a:rPr lang="en-US" smtClean="0"/>
-              <a:t>7/4/2026</a:t>
+              <a:t>9/28/2026</a:t>
             </a:fld>
             <a:endParaRPr lang="en-US"/>
           </a:p>
@@ -1820,7 +1820,7 @@
           <a:p>
             <a:fld id="{41EA29B2-5B60-4524-9406-F439795E8972}" type="datetimeFigureOut">
               <a:rPr lang="en-US" smtClean="0"/>
-              <a:t>7/4/2026</a:t>
+              <a:t>9/28/2026</a:t>
             </a:fld>
             <a:endParaRPr lang="en-US"/>
           </a:p>
@@ -1961,7 +1961,7 @@
           <a:p>
             <a:fld id="{41EA29B2-5B60-4524-9406-F439795E8972}" type="datetimeFigureOut">
               <a:rPr lang="en-US" smtClean="0"/>
-              <a:t>7/4/2026</a:t>
+              <a:t>9/28/2026</a:t>
             </a:fld>
             <a:endParaRPr lang="en-US"/>
           </a:p>
@@ -2074,7 +2074,7 @@
           <a:p>
             <a:fld id="{41EA29B2-5B60-4524-9406-F439795E8972}" type="datetimeFigureOut">
               <a:rPr lang="en-US" smtClean="0"/>
-              <a:t>7/4/2026</a:t>
+              <a:t>9/28/2026</a:t>
             </a:fld>
             <a:endParaRPr lang="en-US"/>
           </a:p>
@@ -2385,7 +2385,7 @@
           <a:p>
             <a:fld id="{41EA29B2-5B60-4524-9406-F439795E8972}" type="datetimeFigureOut">
               <a:rPr lang="en-US" smtClean="0"/>
-              <a:t>7/4/2026</a:t>
+              <a:t>9/28/2026</a:t>
             </a:fld>
             <a:endParaRPr lang="en-US"/>
           </a:p>
@@ -2673,7 +2673,7 @@
           <a:p>
             <a:fld id="{41EA29B2-5B60-4524-9406-F439795E8972}" type="datetimeFigureOut">
               <a:rPr lang="en-US" smtClean="0"/>
-              <a:t>7/4/2026</a:t>
+              <a:t>9/28/2026</a:t>
             </a:fld>
             <a:endParaRPr lang="en-US"/>
           </a:p>
@@ -2914,7 +2914,7 @@
           <a:p>
             <a:fld id="{41EA29B2-5B60-4524-9406-F439795E8972}" type="datetimeFigureOut">
               <a:rPr lang="en-US" smtClean="0"/>
-              <a:t>7/4/2026</a:t>
+              <a:t>9/28/2026</a:t>
             </a:fld>
             <a:endParaRPr lang="en-US"/>
           </a:p>
@@ -3604,7 +3604,7 @@
         </p:spPr>
         <p:txBody>
           <a:bodyPr>
-            <a:normAutofit/>
+            <a:normAutofit fontScale="92500" lnSpcReduction="10000"/>
           </a:bodyPr>
           <a:lstStyle/>
           <a:p>
@@ -3654,7 +3654,10 @@
             </a:r>
           </a:p>
           <a:p>
-            <a:pPr lvl="1"/>
+            <a:pPr marL="914400" lvl="1" indent="-457200">
+              <a:buFont typeface="+mj-lt"/>
+              <a:buAutoNum type="arabicPeriod"/>
+            </a:pPr>
             <a:r>
               <a:rPr lang="en-US" dirty="0"/>
               <a:t>Select a data set and </a:t>
@@ -3665,21 +3668,40 @@
             </a:r>
           </a:p>
           <a:p>
-            <a:pPr lvl="1"/>
+            <a:pPr marL="914400" lvl="1" indent="-457200">
+              <a:buFont typeface="+mj-lt"/>
+              <a:buAutoNum type="arabicPeriod"/>
+            </a:pPr>
             <a:r>
               <a:rPr lang="en-US" dirty="0"/>
               <a:t>Explore and understand the data set in depth</a:t>
             </a:r>
           </a:p>
           <a:p>
-            <a:pPr lvl="1"/>
+            <a:pPr marL="914400" lvl="1" indent="-457200">
+              <a:buFont typeface="+mj-lt"/>
+              <a:buAutoNum type="arabicPeriod"/>
+            </a:pPr>
+            <a:r>
+              <a:rPr lang="en-US" dirty="0"/>
+              <a:t>Submit a project proposal </a:t>
+            </a:r>
+          </a:p>
+          <a:p>
+            <a:pPr marL="914400" lvl="1" indent="-457200">
+              <a:buFont typeface="+mj-lt"/>
+              <a:buAutoNum type="arabicPeriod"/>
+            </a:pPr>
             <a:r>
               <a:rPr lang="en-US" dirty="0"/>
               <a:t>Use data mining methods within the scope of the course to extract information and discover relationships</a:t>
             </a:r>
           </a:p>
           <a:p>
-            <a:pPr lvl="1"/>
+            <a:pPr marL="914400" lvl="1" indent="-457200">
+              <a:buFont typeface="+mj-lt"/>
+              <a:buAutoNum type="arabicPeriod"/>
+            </a:pPr>
             <a:r>
               <a:rPr lang="en-US" dirty="0"/>
               <a:t>Write and submit a professional quality report</a:t>
@@ -3689,6 +3711,20 @@
             <a:r>
               <a:rPr lang="en-US" dirty="0"/>
               <a:t>Please see Assignments tab in Canvas for specific grading criteria </a:t>
+            </a:r>
+          </a:p>
+          <a:p>
+            <a:r>
+              <a:rPr lang="en-US" dirty="0"/>
+              <a:t>Example proposals an reports under the </a:t>
+            </a:r>
+            <a:r>
+              <a:rPr lang="en-US" dirty="0" err="1"/>
+              <a:t>Moduels</a:t>
+            </a:r>
+            <a:r>
+              <a:rPr lang="en-US" dirty="0"/>
+              <a:t> tab in Canvas</a:t>
             </a:r>
           </a:p>
         </p:txBody>
@@ -4007,33 +4043,15 @@
                                   </p:childTnLst>
                                 </p:cTn>
                               </p:par>
-                            </p:childTnLst>
-                          </p:cTn>
-                        </p:par>
-                      </p:childTnLst>
-                    </p:cTn>
-                  </p:par>
-                  <p:par>
-                    <p:cTn id="25" fill="hold">
-                      <p:stCondLst>
-                        <p:cond delay="indefinite"/>
-                      </p:stCondLst>
-                      <p:childTnLst>
-                        <p:par>
-                          <p:cTn id="26" fill="hold">
-                            <p:stCondLst>
-                              <p:cond delay="0"/>
-                            </p:stCondLst>
-                            <p:childTnLst>
                               <p:par>
-                                <p:cTn id="27" presetID="1" presetClass="entr" presetSubtype="0" fill="hold" nodeType="clickEffect">
+                                <p:cTn id="25" presetID="1" presetClass="entr" presetSubtype="0" fill="hold" nodeType="withEffect">
                                   <p:stCondLst>
                                     <p:cond delay="0"/>
                                   </p:stCondLst>
                                   <p:childTnLst>
                                     <p:set>
                                       <p:cBhvr>
-                                        <p:cTn id="28" dur="1" fill="hold">
+                                        <p:cTn id="26" dur="1" fill="hold">
                                           <p:stCondLst>
                                             <p:cond delay="0"/>
                                           </p:stCondLst>
@@ -4042,6 +4060,104 @@
                                           <p:spTgt spid="3">
                                             <p:txEl>
                                               <p:pRg st="9" end="9"/>
+                                            </p:txEl>
+                                          </p:spTgt>
+                                        </p:tgtEl>
+                                        <p:attrNameLst>
+                                          <p:attrName>style.visibility</p:attrName>
+                                        </p:attrNameLst>
+                                      </p:cBhvr>
+                                      <p:to>
+                                        <p:strVal val="visible"/>
+                                      </p:to>
+                                    </p:set>
+                                  </p:childTnLst>
+                                </p:cTn>
+                              </p:par>
+                            </p:childTnLst>
+                          </p:cTn>
+                        </p:par>
+                      </p:childTnLst>
+                    </p:cTn>
+                  </p:par>
+                  <p:par>
+                    <p:cTn id="27" fill="hold">
+                      <p:stCondLst>
+                        <p:cond delay="indefinite"/>
+                      </p:stCondLst>
+                      <p:childTnLst>
+                        <p:par>
+                          <p:cTn id="28" fill="hold">
+                            <p:stCondLst>
+                              <p:cond delay="0"/>
+                            </p:stCondLst>
+                            <p:childTnLst>
+                              <p:par>
+                                <p:cTn id="29" presetID="1" presetClass="entr" presetSubtype="0" fill="hold" nodeType="clickEffect">
+                                  <p:stCondLst>
+                                    <p:cond delay="0"/>
+                                  </p:stCondLst>
+                                  <p:childTnLst>
+                                    <p:set>
+                                      <p:cBhvr>
+                                        <p:cTn id="30" dur="1" fill="hold">
+                                          <p:stCondLst>
+                                            <p:cond delay="0"/>
+                                          </p:stCondLst>
+                                        </p:cTn>
+                                        <p:tgtEl>
+                                          <p:spTgt spid="3">
+                                            <p:txEl>
+                                              <p:pRg st="10" end="10"/>
+                                            </p:txEl>
+                                          </p:spTgt>
+                                        </p:tgtEl>
+                                        <p:attrNameLst>
+                                          <p:attrName>style.visibility</p:attrName>
+                                        </p:attrNameLst>
+                                      </p:cBhvr>
+                                      <p:to>
+                                        <p:strVal val="visible"/>
+                                      </p:to>
+                                    </p:set>
+                                  </p:childTnLst>
+                                </p:cTn>
+                              </p:par>
+                            </p:childTnLst>
+                          </p:cTn>
+                        </p:par>
+                      </p:childTnLst>
+                    </p:cTn>
+                  </p:par>
+                  <p:par>
+                    <p:cTn id="31" fill="hold">
+                      <p:stCondLst>
+                        <p:cond delay="indefinite"/>
+                      </p:stCondLst>
+                      <p:childTnLst>
+                        <p:par>
+                          <p:cTn id="32" fill="hold">
+                            <p:stCondLst>
+                              <p:cond delay="0"/>
+                            </p:stCondLst>
+                            <p:childTnLst>
+                              <p:par>
+                                <p:cTn id="33" presetID="1" presetClass="entr" presetSubtype="0" fill="hold" nodeType="clickEffect">
+                                  <p:stCondLst>
+                                    <p:cond delay="0"/>
+                                  </p:stCondLst>
+                                  <p:childTnLst>
+                                    <p:set>
+                                      <p:cBhvr>
+                                        <p:cTn id="34" dur="1" fill="hold">
+                                          <p:stCondLst>
+                                            <p:cond delay="0"/>
+                                          </p:stCondLst>
+                                        </p:cTn>
+                                        <p:tgtEl>
+                                          <p:spTgt spid="3">
+                                            <p:txEl>
+                                              <p:pRg st="11" end="11"/>
                                             </p:txEl>
                                           </p:spTgt>
                                         </p:tgtEl>
@@ -4241,7 +4357,15 @@
             </a:r>
             <a:r>
               <a:rPr lang="en-US" dirty="0"/>
-              <a:t>, e.g. clustering project must go beyond k-means and apply several modern methods!</a:t>
+              <a:t>, e.g. clustering project must go beyond k-means and </a:t>
+            </a:r>
+            <a:r>
+              <a:rPr lang="en-US" b="1" dirty="0">
+                <a:solidFill>
+                  <a:srgbClr val="FF0000"/>
+                </a:solidFill>
+              </a:rPr>
+              <a:t>apply several modern methods!</a:t>
             </a:r>
           </a:p>
           <a:p>
@@ -4766,7 +4890,7 @@
             <a:pPr lvl="1"/>
             <a:r>
               <a:rPr lang="en-US" dirty="0"/>
-              <a:t>Recommenders</a:t>
+              <a:t>Recommenders – can be supervised </a:t>
             </a:r>
           </a:p>
           <a:p>
@@ -4779,8 +4903,16 @@
           <a:p>
             <a:pPr lvl="1"/>
             <a:r>
+              <a:rPr lang="en-US" b="1" dirty="0">
+                <a:solidFill>
+                  <a:srgbClr val="FF0000"/>
+                </a:solidFill>
+              </a:rPr>
+              <a:t>No supervised machine learning</a:t>
+            </a:r>
+            <a:r>
               <a:rPr lang="en-US" b="1" dirty="0"/>
-              <a:t>No standard supervised machine learning, e.g. no regression or classification!</a:t>
+              <a:t>, e.g. no predictive models such as regression or classification!</a:t>
             </a:r>
           </a:p>
           <a:p>
@@ -4800,7 +4932,7 @@
             <a:pPr lvl="1"/>
             <a:r>
               <a:rPr lang="en-US" dirty="0"/>
-              <a:t>Text data, information retrieval, similarity search, etc.</a:t>
+              <a:t>Text, image and audio data, information retrieval, similarity search, etc.</a:t>
             </a:r>
           </a:p>
           <a:p>
@@ -5407,7 +5539,7 @@
         </p:spPr>
         <p:txBody>
           <a:bodyPr>
-            <a:normAutofit lnSpcReduction="10000"/>
+            <a:normAutofit fontScale="92500" lnSpcReduction="10000"/>
           </a:bodyPr>
           <a:lstStyle/>
           <a:p>
@@ -5450,7 +5582,7 @@
             <a:pPr lvl="1"/>
             <a:r>
               <a:rPr lang="en-US" dirty="0"/>
-              <a:t>Sufficient depth – depth of data exploration, depth of analysis</a:t>
+              <a:t>Sufficient of analysis and modeling</a:t>
             </a:r>
           </a:p>
           <a:p>
@@ -5503,13 +5635,24 @@
             </a:r>
           </a:p>
           <a:p>
+            <a:pPr lvl="1"/>
+            <a:r>
+              <a:rPr lang="en-US" b="1" dirty="0">
+                <a:solidFill>
+                  <a:srgbClr val="C00000"/>
+                </a:solidFill>
+              </a:rPr>
+              <a:t>Outline data preparation steps  </a:t>
+            </a:r>
+          </a:p>
+          <a:p>
             <a:pPr marL="514350" indent="-514350">
               <a:buFont typeface="+mj-lt"/>
               <a:buAutoNum type="arabicPeriod"/>
             </a:pPr>
             <a:r>
               <a:rPr lang="en-US" dirty="0"/>
-              <a:t>Use appropriate data mining methods</a:t>
+              <a:t>Discuss appropriate data mining algorithms</a:t>
             </a:r>
           </a:p>
           <a:p>
@@ -5522,9 +5665,22 @@
           <a:p>
             <a:pPr lvl="1"/>
             <a:r>
+              <a:rPr lang="en-US" b="1" dirty="0">
+                <a:solidFill>
+                  <a:srgbClr val="C00000"/>
+                </a:solidFill>
+              </a:rPr>
+              <a:t>In scope of course</a:t>
+            </a:r>
+            <a:r>
               <a:rPr lang="en-US" dirty="0"/>
-              <a:t>In scope of course</a:t>
-            </a:r>
+              <a:t> – see syllabus </a:t>
+            </a:r>
+            <a:endParaRPr lang="en-US" b="1" dirty="0">
+              <a:solidFill>
+                <a:srgbClr val="C00000"/>
+              </a:solidFill>
+            </a:endParaRPr>
           </a:p>
           <a:p>
             <a:endParaRPr lang="en-US" dirty="0"/>
@@ -5911,33 +6067,15 @@
                                   </p:childTnLst>
                                 </p:cTn>
                               </p:par>
-                            </p:childTnLst>
-                          </p:cTn>
-                        </p:par>
-                      </p:childTnLst>
-                    </p:cTn>
-                  </p:par>
-                  <p:par>
-                    <p:cTn id="29" fill="hold">
-                      <p:stCondLst>
-                        <p:cond delay="indefinite"/>
-                      </p:stCondLst>
-                      <p:childTnLst>
-                        <p:par>
-                          <p:cTn id="30" fill="hold">
-                            <p:stCondLst>
-                              <p:cond delay="0"/>
-                            </p:stCondLst>
-                            <p:childTnLst>
                               <p:par>
-                                <p:cTn id="31" presetID="1" presetClass="entr" presetSubtype="0" fill="hold" nodeType="clickEffect">
+                                <p:cTn id="29" presetID="1" presetClass="entr" presetSubtype="0" fill="hold" nodeType="withEffect">
                                   <p:stCondLst>
                                     <p:cond delay="0"/>
                                   </p:stCondLst>
                                   <p:childTnLst>
                                     <p:set>
                                       <p:cBhvr>
-                                        <p:cTn id="32" dur="1" fill="hold">
+                                        <p:cTn id="30" dur="1" fill="hold">
                                           <p:stCondLst>
                                             <p:cond delay="0"/>
                                           </p:stCondLst>
@@ -5960,8 +6098,26 @@
                                   </p:childTnLst>
                                 </p:cTn>
                               </p:par>
+                            </p:childTnLst>
+                          </p:cTn>
+                        </p:par>
+                      </p:childTnLst>
+                    </p:cTn>
+                  </p:par>
+                  <p:par>
+                    <p:cTn id="31" fill="hold">
+                      <p:stCondLst>
+                        <p:cond delay="indefinite"/>
+                      </p:stCondLst>
+                      <p:childTnLst>
+                        <p:par>
+                          <p:cTn id="32" fill="hold">
+                            <p:stCondLst>
+                              <p:cond delay="0"/>
+                            </p:stCondLst>
+                            <p:childTnLst>
                               <p:par>
-                                <p:cTn id="33" presetID="1" presetClass="entr" presetSubtype="0" fill="hold" nodeType="withEffect">
+                                <p:cTn id="33" presetID="1" presetClass="entr" presetSubtype="0" fill="hold" nodeType="clickEffect">
                                   <p:stCondLst>
                                     <p:cond delay="0"/>
                                   </p:stCondLst>
@@ -6008,6 +6164,37 @@
                                           <p:spTgt spid="3">
                                             <p:txEl>
                                               <p:pRg st="13" end="13"/>
+                                            </p:txEl>
+                                          </p:spTgt>
+                                        </p:tgtEl>
+                                        <p:attrNameLst>
+                                          <p:attrName>style.visibility</p:attrName>
+                                        </p:attrNameLst>
+                                      </p:cBhvr>
+                                      <p:to>
+                                        <p:strVal val="visible"/>
+                                      </p:to>
+                                    </p:set>
+                                  </p:childTnLst>
+                                </p:cTn>
+                              </p:par>
+                              <p:par>
+                                <p:cTn id="37" presetID="1" presetClass="entr" presetSubtype="0" fill="hold" nodeType="withEffect">
+                                  <p:stCondLst>
+                                    <p:cond delay="0"/>
+                                  </p:stCondLst>
+                                  <p:childTnLst>
+                                    <p:set>
+                                      <p:cBhvr>
+                                        <p:cTn id="38" dur="1" fill="hold">
+                                          <p:stCondLst>
+                                            <p:cond delay="0"/>
+                                          </p:stCondLst>
+                                        </p:cTn>
+                                        <p:tgtEl>
+                                          <p:spTgt spid="3">
+                                            <p:txEl>
+                                              <p:pRg st="14" end="14"/>
                                             </p:txEl>
                                           </p:spTgt>
                                         </p:tgtEl>
@@ -6131,7 +6318,7 @@
         </p:spPr>
         <p:txBody>
           <a:bodyPr>
-            <a:normAutofit fontScale="92500" lnSpcReduction="10000"/>
+            <a:normAutofit fontScale="92500" lnSpcReduction="20000"/>
           </a:bodyPr>
           <a:lstStyle/>
           <a:p>
@@ -6140,7 +6327,19 @@
             </a:pPr>
             <a:r>
               <a:rPr lang="en-US" b="1" dirty="0"/>
-              <a:t>You will submit a professional quality project report, </a:t>
+              <a:t>You will submit a professional quality project report in </a:t>
+            </a:r>
+            <a:r>
+              <a:rPr lang="en-US" b="1" dirty="0">
+                <a:solidFill>
+                  <a:srgbClr val="C00000"/>
+                </a:solidFill>
+              </a:rPr>
+              <a:t>one Jupyter notebook</a:t>
+            </a:r>
+            <a:r>
+              <a:rPr lang="en-US" b="1" dirty="0"/>
+              <a:t>, </a:t>
             </a:r>
             <a:r>
               <a:rPr lang="en-US" dirty="0"/>
@@ -6197,8 +6396,12 @@
           <a:p>
             <a:pPr lvl="1"/>
             <a:r>
-              <a:rPr lang="en-US" dirty="0"/>
-              <a:t>Clear text and graphics  </a:t>
+              <a:rPr lang="en-US" b="1" dirty="0">
+                <a:solidFill>
+                  <a:srgbClr val="C00000"/>
+                </a:solidFill>
+              </a:rPr>
+              <a:t>Must include both explanatory text and graphics  </a:t>
             </a:r>
           </a:p>
           <a:p>
@@ -6227,6 +6430,17 @@
             <a:r>
               <a:rPr lang="en-US" b="1" dirty="0"/>
               <a:t>enhancing methods or using other algorithms</a:t>
+            </a:r>
+          </a:p>
+          <a:p>
+            <a:pPr lvl="1"/>
+            <a:r>
+              <a:rPr lang="en-US" dirty="0"/>
+              <a:t>Properly apply up to date algorithms</a:t>
+            </a:r>
+            <a:r>
+              <a:rPr lang="en-US" b="1" dirty="0"/>
+              <a:t> </a:t>
             </a:r>
           </a:p>
           <a:p>
@@ -6629,33 +6843,15 @@
                                   </p:childTnLst>
                                 </p:cTn>
                               </p:par>
-                            </p:childTnLst>
-                          </p:cTn>
-                        </p:par>
-                      </p:childTnLst>
-                    </p:cTn>
-                  </p:par>
-                  <p:par>
-                    <p:cTn id="31" fill="hold">
-                      <p:stCondLst>
-                        <p:cond delay="indefinite"/>
-                      </p:stCondLst>
-                      <p:childTnLst>
-                        <p:par>
-                          <p:cTn id="32" fill="hold">
-                            <p:stCondLst>
-                              <p:cond delay="0"/>
-                            </p:stCondLst>
-                            <p:childTnLst>
                               <p:par>
-                                <p:cTn id="33" presetID="1" presetClass="entr" presetSubtype="0" fill="hold" nodeType="clickEffect">
+                                <p:cTn id="31" presetID="1" presetClass="entr" presetSubtype="0" fill="hold" nodeType="withEffect">
                                   <p:stCondLst>
                                     <p:cond delay="0"/>
                                   </p:stCondLst>
                                   <p:childTnLst>
                                     <p:set>
                                       <p:cBhvr>
-                                        <p:cTn id="34" dur="1" fill="hold">
+                                        <p:cTn id="32" dur="1" fill="hold">
                                           <p:stCondLst>
                                             <p:cond delay="0"/>
                                           </p:stCondLst>
@@ -6664,6 +6860,55 @@
                                           <p:spTgt spid="3">
                                             <p:txEl>
                                               <p:pRg st="10" end="10"/>
+                                            </p:txEl>
+                                          </p:spTgt>
+                                        </p:tgtEl>
+                                        <p:attrNameLst>
+                                          <p:attrName>style.visibility</p:attrName>
+                                        </p:attrNameLst>
+                                      </p:cBhvr>
+                                      <p:to>
+                                        <p:strVal val="visible"/>
+                                      </p:to>
+                                    </p:set>
+                                  </p:childTnLst>
+                                </p:cTn>
+                              </p:par>
+                            </p:childTnLst>
+                          </p:cTn>
+                        </p:par>
+                      </p:childTnLst>
+                    </p:cTn>
+                  </p:par>
+                  <p:par>
+                    <p:cTn id="33" fill="hold">
+                      <p:stCondLst>
+                        <p:cond delay="indefinite"/>
+                      </p:stCondLst>
+                      <p:childTnLst>
+                        <p:par>
+                          <p:cTn id="34" fill="hold">
+                            <p:stCondLst>
+                              <p:cond delay="0"/>
+                            </p:stCondLst>
+                            <p:childTnLst>
+                              <p:par>
+                                <p:cTn id="35" presetID="1" presetClass="entr" presetSubtype="0" fill="hold" nodeType="clickEffect">
+                                  <p:stCondLst>
+                                    <p:cond delay="0"/>
+                                  </p:stCondLst>
+                                  <p:childTnLst>
+                                    <p:set>
+                                      <p:cBhvr>
+                                        <p:cTn id="36" dur="1" fill="hold">
+                                          <p:stCondLst>
+                                            <p:cond delay="0"/>
+                                          </p:stCondLst>
+                                        </p:cTn>
+                                        <p:tgtEl>
+                                          <p:spTgt spid="3">
+                                            <p:txEl>
+                                              <p:pRg st="11" end="11"/>
                                             </p:txEl>
                                           </p:spTgt>
                                         </p:tgtEl>

</xml_diff>

<commit_message>
Update from section meeting
</commit_message>
<xml_diff>
--- a/SupplementaryMaterials/GraduateIndependentProject.pptx
+++ b/SupplementaryMaterials/GraduateIndependentProject.pptx
@@ -4854,7 +4854,7 @@
         </p:spPr>
         <p:txBody>
           <a:bodyPr>
-            <a:normAutofit lnSpcReduction="10000"/>
+            <a:normAutofit fontScale="92500" lnSpcReduction="10000"/>
           </a:bodyPr>
           <a:lstStyle/>
           <a:p>
@@ -4884,6 +4884,13 @@
             <a:r>
               <a:rPr lang="en-US" dirty="0"/>
               <a:t>Large scale similarity searches </a:t>
+            </a:r>
+          </a:p>
+          <a:p>
+            <a:pPr lvl="1"/>
+            <a:r>
+              <a:rPr lang="en-US" dirty="0"/>
+              <a:t>Online algorithms</a:t>
             </a:r>
           </a:p>
           <a:p>
@@ -5195,33 +5202,15 @@
                                   </p:childTnLst>
                                 </p:cTn>
                               </p:par>
-                            </p:childTnLst>
-                          </p:cTn>
-                        </p:par>
-                      </p:childTnLst>
-                    </p:cTn>
-                  </p:par>
-                  <p:par>
-                    <p:cTn id="17" fill="hold">
-                      <p:stCondLst>
-                        <p:cond delay="indefinite"/>
-                      </p:stCondLst>
-                      <p:childTnLst>
-                        <p:par>
-                          <p:cTn id="18" fill="hold">
-                            <p:stCondLst>
-                              <p:cond delay="0"/>
-                            </p:stCondLst>
-                            <p:childTnLst>
                               <p:par>
-                                <p:cTn id="19" presetID="1" presetClass="entr" presetSubtype="0" fill="hold" nodeType="clickEffect">
+                                <p:cTn id="17" presetID="1" presetClass="entr" presetSubtype="0" fill="hold" nodeType="withEffect">
                                   <p:stCondLst>
                                     <p:cond delay="0"/>
                                   </p:stCondLst>
                                   <p:childTnLst>
                                     <p:set>
                                       <p:cBhvr>
-                                        <p:cTn id="20" dur="1" fill="hold">
+                                        <p:cTn id="18" dur="1" fill="hold">
                                           <p:stCondLst>
                                             <p:cond delay="0"/>
                                           </p:stCondLst>
@@ -5244,8 +5233,26 @@
                                   </p:childTnLst>
                                 </p:cTn>
                               </p:par>
+                            </p:childTnLst>
+                          </p:cTn>
+                        </p:par>
+                      </p:childTnLst>
+                    </p:cTn>
+                  </p:par>
+                  <p:par>
+                    <p:cTn id="19" fill="hold">
+                      <p:stCondLst>
+                        <p:cond delay="indefinite"/>
+                      </p:stCondLst>
+                      <p:childTnLst>
+                        <p:par>
+                          <p:cTn id="20" fill="hold">
+                            <p:stCondLst>
+                              <p:cond delay="0"/>
+                            </p:stCondLst>
+                            <p:childTnLst>
                               <p:par>
-                                <p:cTn id="21" presetID="1" presetClass="entr" presetSubtype="0" fill="hold" nodeType="withEffect">
+                                <p:cTn id="21" presetID="1" presetClass="entr" presetSubtype="0" fill="hold" nodeType="clickEffect">
                                   <p:stCondLst>
                                     <p:cond delay="0"/>
                                   </p:stCondLst>
@@ -5416,6 +5423,37 @@
                                           <p:spTgt spid="3">
                                             <p:txEl>
                                               <p:pRg st="13" end="13"/>
+                                            </p:txEl>
+                                          </p:spTgt>
+                                        </p:tgtEl>
+                                        <p:attrNameLst>
+                                          <p:attrName>style.visibility</p:attrName>
+                                        </p:attrNameLst>
+                                      </p:cBhvr>
+                                      <p:to>
+                                        <p:strVal val="visible"/>
+                                      </p:to>
+                                    </p:set>
+                                  </p:childTnLst>
+                                </p:cTn>
+                              </p:par>
+                              <p:par>
+                                <p:cTn id="33" presetID="1" presetClass="entr" presetSubtype="0" fill="hold" nodeType="withEffect">
+                                  <p:stCondLst>
+                                    <p:cond delay="0"/>
+                                  </p:stCondLst>
+                                  <p:childTnLst>
+                                    <p:set>
+                                      <p:cBhvr>
+                                        <p:cTn id="34" dur="1" fill="hold">
+                                          <p:stCondLst>
+                                            <p:cond delay="0"/>
+                                          </p:stCondLst>
+                                        </p:cTn>
+                                        <p:tgtEl>
+                                          <p:spTgt spid="3">
+                                            <p:txEl>
+                                              <p:pRg st="14" end="14"/>
                                             </p:txEl>
                                           </p:spTgt>
                                         </p:tgtEl>

</xml_diff>